<commit_message>
Agrandar el logo en la portada y aceptar PNG o JPG
El logo de la portada pasa de 2 a 3,25 pulgadas, como se acostumbra en
material institucional. La marca de agua MEDELLIN TE QUIERE se reduce de
58 a 48 pt para dejarle aire, porque a 58 quedaba pegada a la placa.

El generador ahora mide el alto real de la imagen leyendo la cabecera del
archivo, sea PNG (IHDR) o JPG (marcador SOF), y busca logo.png, logo.jpg,
logo.jpeg, logo/logo.png o ../logo.png. Asi el logo nunca se deforma, dé
el formato que dé. Si no encuentra ninguno avisa por consola y deja el
recuadro punteado.

Probado de punta a punta con una imagen de 350x130: se ubica y se escala
bien en la portada y en las laminas azules.

Co-Authored-By: Claude Opus 5 <noreply@anthropic.com>
Claude-Session: https://claude.ai/code/session_019jU79SFwV3wovCjas6Jao1
</commit_message>
<xml_diff>
--- a/docs/proyectos/personas-mayores/PPT_Sesion_5_COMBINADA.pptx
+++ b/docs/proyectos/personas-mayores/PPT_Sesion_5_COMBINADA.pptx
@@ -3642,8 +3642,8 @@
         </p:nvSpPr>
         <p:spPr>
           <a:xfrm>
-            <a:off x="9619488" y="182880"/>
-            <a:ext cx="2011680" cy="859536"/>
+            <a:off x="8394192" y="256032"/>
+            <a:ext cx="3227832" cy="1355598"/>
           </a:xfrm>
           <a:prstGeom prst="rect">
             <a:avLst/>
@@ -3662,8 +3662,8 @@
         </p:nvSpPr>
         <p:spPr>
           <a:xfrm>
-            <a:off x="9710928" y="274320"/>
-            <a:ext cx="1828800" cy="676656"/>
+            <a:off x="8522208" y="384048"/>
+            <a:ext cx="2971800" cy="1099566"/>
           </a:xfrm>
           <a:prstGeom prst="rect">
             <a:avLst/>
@@ -3687,8 +3687,8 @@
         </p:nvSpPr>
         <p:spPr>
           <a:xfrm>
-            <a:off x="9710928" y="274320"/>
-            <a:ext cx="1828800" cy="676656"/>
+            <a:off x="8522208" y="384048"/>
+            <a:ext cx="2971800" cy="1099566"/>
           </a:xfrm>
           <a:prstGeom prst="rect">
             <a:avLst/>
@@ -3704,7 +3704,7 @@
               <a:buNone/>
             </a:pPr>
             <a:r>
-              <a:rPr lang="en-US" sz="1200" b="1" spc="200" kern="0" dirty="0">
+              <a:rPr lang="en-US" sz="1500" b="1" spc="200" kern="0" dirty="0">
                 <a:solidFill>
                   <a:srgbClr val="8FA3B0"/>
                 </a:solidFill>
@@ -3714,7 +3714,7 @@
               </a:rPr>
               <a:t>LOGO</a:t>
             </a:r>
-            <a:endParaRPr lang="en-US" sz="1200" dirty="0"/>
+            <a:endParaRPr lang="en-US" sz="1500" dirty="0"/>
           </a:p>
         </p:txBody>
       </p:sp>
@@ -3726,8 +3726,8 @@
         </p:nvSpPr>
         <p:spPr>
           <a:xfrm>
-            <a:off x="4480560" y="274320"/>
-            <a:ext cx="7315200" cy="868680"/>
+            <a:off x="4480560" y="384048"/>
+            <a:ext cx="3840480" cy="749808"/>
           </a:xfrm>
           <a:prstGeom prst="rect">
             <a:avLst/>
@@ -3743,7 +3743,7 @@
               <a:buNone/>
             </a:pPr>
             <a:r>
-              <a:rPr lang="en-US" sz="5800" b="1" dirty="0">
+              <a:rPr lang="en-US" sz="4800" b="1" dirty="0">
                 <a:solidFill>
                   <a:srgbClr val="15455F"/>
                 </a:solidFill>
@@ -3753,7 +3753,7 @@
               </a:rPr>
               <a:t>MEDELLÍN</a:t>
             </a:r>
-            <a:endParaRPr lang="en-US" sz="5800" dirty="0"/>
+            <a:endParaRPr lang="en-US" sz="4800" dirty="0"/>
           </a:p>
         </p:txBody>
       </p:sp>
@@ -3765,8 +3765,8 @@
         </p:nvSpPr>
         <p:spPr>
           <a:xfrm>
-            <a:off x="4480560" y="1005840"/>
-            <a:ext cx="7315200" cy="868680"/>
+            <a:off x="4480560" y="1024128"/>
+            <a:ext cx="3840480" cy="749808"/>
           </a:xfrm>
           <a:prstGeom prst="rect">
             <a:avLst/>
@@ -3782,7 +3782,7 @@
               <a:buNone/>
             </a:pPr>
             <a:r>
-              <a:rPr lang="en-US" sz="5800" b="1" dirty="0">
+              <a:rPr lang="en-US" sz="4800" b="1" dirty="0">
                 <a:solidFill>
                   <a:srgbClr val="15455F"/>
                 </a:solidFill>
@@ -3792,7 +3792,7 @@
               </a:rPr>
               <a:t>TE QUIERE</a:t>
             </a:r>
-            <a:endParaRPr lang="en-US" sz="5800" dirty="0"/>
+            <a:endParaRPr lang="en-US" sz="4800" dirty="0"/>
           </a:p>
         </p:txBody>
       </p:sp>

</xml_diff>